<commit_message>
Send a Telegram summary after every check run; add Gemini challenge slide
- watchagent check --notify now sends one summary per run: how many
  watches were checked, the verdict counts, and each failed or skipped
  watch with a plain reason (AI quota used up, AI service busy, no usable
  listing found). A quiet chat no longer hides failed checks.
- Deck: new slide 12 on the current Gemini free-tier bottleneck (backup
  model capped at 20 requests a day, overloads, options), from the
  22-23 Sep run logs.
</commit_message>
<xml_diff>
--- a/docs/WatchAgent_Agentic_AI_Brownbag.pptx
+++ b/docs/WatchAgent_Agentic_AI_Brownbag.pptx
@@ -16,6 +16,7 @@
     <p:sldId id="270" r:id="rId21"/>
     <p:sldId id="260" r:id="rId6"/>
     <p:sldId id="261" r:id="rId7"/>
+    <p:sldId id="271" r:id="rId22"/>
     <p:sldId id="262" r:id="rId8"/>
     <p:sldId id="263" r:id="rId9"/>
     <p:sldId id="264" r:id="rId10"/>
@@ -1457,6 +1458,94 @@
             <a:r>
               <a:rPr lang="en-US" dirty="0"/>
               <a:t>These are the five boxes from the diagram, in plain terms. Three do the work. watchagent check is the scheduler: every six hours it picks the watches that have gone longest without a check, researches three at a time, and sends a Telegram alert when one is a good buy. The research agent is the AI researcher: it searches, opens listings, and keeps handing in what it finds until three listings of the exact watch are accepted. The Telegram assistant is your chat window: it answers questions and can run a fresh check, but it can only suggest changes, and nothing happens until you tap Confirm. Two keep that work honest. The listing checks are plain code, no AI: a price counts only if it is really on the page, for the exact reference, and not far off the others; the middle price is recorded and the verdict is simple arithmetic. The model middleware wraps every AI call: it makes the AI research before answering, retries when the service is busy, switches to a backup model, caps the steps, and keeps a daily limit so the assistant always has requests left.</a:t>
+            </a:r>
+            <a:endParaRPr lang="en-US" dirty="0"/>
+          </a:p>
+        </p:txBody>
+      </p:sp>
+      <p:sp>
+        <p:nvSpPr>
+          <p:cNvPr id="4" name="Slide Number Placeholder 3"/>
+          <p:cNvSpPr>
+            <a:spLocks noGrp="1"/>
+          </p:cNvSpPr>
+          <p:nvPr>
+            <p:ph type="sldNum" sz="quarter" idx="10"/>
+          </p:nvPr>
+        </p:nvSpPr>
+        <p:spPr/>
+        <p:txBody>
+          <a:bodyPr/>
+          <a:lstStyle/>
+          <a:p>
+            <a:fld id="{F7021451-1387-4CA6-816F-3879F97B5CBC}" type="slidenum">
+              <a:rPr lang="en-US"/>
+              <a:t>4</a:t>
+            </a:fld>
+            <a:endParaRPr lang="en-US"/>
+          </a:p>
+        </p:txBody>
+      </p:sp>
+    </p:spTree>
+    <p:extLst>
+      <p:ext uri="{BB962C8B-B14F-4D97-AF65-F5344CB8AC3E}">
+        <p14:creationId xmlns:p14="http://schemas.microsoft.com/office/powerpoint/2010/main" val="1024086991"/>
+      </p:ext>
+    </p:extLst>
+  </p:cSld>
+  <p:clrMapOvr>
+    <a:masterClrMapping/>
+  </p:clrMapOvr>
+</p:notes>
+</file>
+
+<file path=ppt/notesSlides/notesSlide16.xml><?xml version="1.0" encoding="utf-8"?>
+<p:notes xmlns:a="http://schemas.openxmlformats.org/drawingml/2006/main" xmlns:r="http://schemas.openxmlformats.org/officeDocument/2006/relationships" xmlns:p="http://schemas.openxmlformats.org/presentationml/2006/main">
+  <p:cSld>
+    <p:spTree>
+      <p:nvGrpSpPr>
+        <p:cNvPr id="1" name=""/>
+        <p:cNvGrpSpPr/>
+        <p:nvPr/>
+      </p:nvGrpSpPr>
+      <p:grpSpPr>
+        <a:xfrm>
+          <a:off x="0" y="0"/>
+          <a:ext cx="0" cy="0"/>
+          <a:chOff x="0" y="0"/>
+          <a:chExt cx="0" cy="0"/>
+        </a:xfrm>
+      </p:grpSpPr>
+      <p:sp>
+        <p:nvSpPr>
+          <p:cNvPr id="2" name="Slide Image Placeholder 1"/>
+          <p:cNvSpPr>
+            <a:spLocks noGrp="1" noRot="1" noChangeAspect="1"/>
+          </p:cNvSpPr>
+          <p:nvPr>
+            <p:ph type="sldImg"/>
+          </p:nvPr>
+        </p:nvSpPr>
+        <p:spPr/>
+      </p:sp>
+      <p:sp>
+        <p:nvSpPr>
+          <p:cNvPr id="3" name="Notes Placeholder 2"/>
+          <p:cNvSpPr>
+            <a:spLocks noGrp="1"/>
+          </p:cNvSpPr>
+          <p:nvPr>
+            <p:ph type="body" idx="1"/>
+          </p:nvPr>
+        </p:nvSpPr>
+        <p:spPr/>
+        <p:txBody>
+          <a:bodyPr/>
+          <a:lstStyle/>
+          <a:p>
+            <a:r>
+              <a:rPr lang="en-US" dirty="0"/>
+              <a:t>An honest status update. WatchAgent runs on Google's free Gemini tier. This week the main model, flash-lite, was overloaded most of the time, so calls took 40 to 60 seconds and often failed. When that happens the agent switches to a backup model, gemini-3.5-flash, but its free tier allows only 20 requests a day, and one watch check needs five to eight. In the last two scheduled runs, 10 of 20 checks failed on that limit and 4 more found no usable listing. What you notice: most prices go stale, BUY alerts can't fire for watches that weren't checked, and because failures are not sent to Telegram, silence looks the same as nothing worth buying. We also tried free models on OpenRouter; they were either rate-limited or didn't use tools properly. The options are on the right: pay for capacity, swap the backup for a model with its own free quota, check less, and send a Telegram summary after every run so failures are visible.</a:t>
             </a:r>
             <a:endParaRPr lang="en-US" dirty="0"/>
           </a:p>
@@ -2871,7 +2960,7 @@
                 <a:ea typeface="Arial" pitchFamily="34" charset="-122"/>
                 <a:cs typeface="Arial" pitchFamily="34" charset="-120"/>
               </a:rPr>
-              <a:t>15</a:t>
+              <a:t>16</a:t>
             </a:r>
             <a:endParaRPr lang="en-US" sz="900" dirty="0"/>
           </a:p>
@@ -8156,6 +8245,1196 @@
 </p:sld>
 </file>
 
+<file path=ppt/slides/slide16.xml><?xml version="1.0" encoding="utf-8"?>
+<p:sld xmlns:a="http://schemas.openxmlformats.org/drawingml/2006/main" xmlns:r="http://schemas.openxmlformats.org/officeDocument/2006/relationships" xmlns:p="http://schemas.openxmlformats.org/presentationml/2006/main">
+  <p:cSld name="Slide 4">
+    <p:bg>
+      <p:bgPr>
+        <a:solidFill>
+          <a:srgbClr val="FFFFFF"/>
+        </a:solidFill>
+      </p:bgPr>
+    </p:bg>
+    <p:spTree>
+      <p:nvGrpSpPr>
+        <p:cNvPr id="1" name=""/>
+        <p:cNvGrpSpPr/>
+        <p:nvPr/>
+      </p:nvGrpSpPr>
+      <p:grpSpPr>
+        <a:xfrm>
+          <a:off x="0" y="0"/>
+          <a:ext cx="0" cy="0"/>
+          <a:chOff x="0" y="0"/>
+          <a:chExt cx="0" cy="0"/>
+        </a:xfrm>
+      </p:grpSpPr>
+      <p:sp>
+        <p:nvSpPr>
+          <p:cNvPr id="2" name="Text 0"/>
+          <p:cNvSpPr txBox="1"/>
+          <p:nvPr/>
+        </p:nvSpPr>
+        <p:spPr>
+          <a:xfrm>
+            <a:off x="548640" y="274320"/>
+            <a:ext cx="7315200" cy="228600"/>
+          </a:xfrm>
+          <a:prstGeom prst="rect">
+            <a:avLst/>
+          </a:prstGeom>
+          <a:noFill/>
+          <a:ln/>
+        </p:spPr>
+        <p:txBody>
+          <a:bodyPr wrap="square" lIns="0" tIns="0" rIns="0" bIns="0" rtlCol="0" anchor="t"/>
+          <a:lstStyle/>
+          <a:p>
+            <a:pPr indent="0" marL="0">
+              <a:buNone/>
+            </a:pPr>
+            <a:r>
+              <a:rPr lang="en-US" sz="1000" b="1" spc="200" kern="0" dirty="0">
+                <a:solidFill>
+                  <a:srgbClr val="2251FF"/>
+                </a:solidFill>
+                <a:latin typeface="Arial" pitchFamily="34" charset="0"/>
+                <a:ea typeface="Arial" pitchFamily="34" charset="-122"/>
+                <a:cs typeface="Arial" pitchFamily="34" charset="-120"/>
+              </a:rPr>
+              <a:t>CURRENT CHALLENGE: THE AI PROVIDER</a:t>
+            </a:r>
+            <a:endParaRPr lang="en-US" sz="1000" dirty="0"/>
+          </a:p>
+        </p:txBody>
+      </p:sp>
+      <p:sp>
+        <p:nvSpPr>
+          <p:cNvPr id="3" name="Text 1"/>
+          <p:cNvSpPr txBox="1"/>
+          <p:nvPr/>
+        </p:nvSpPr>
+        <p:spPr>
+          <a:xfrm>
+            <a:off x="548640" y="594360"/>
+            <a:ext cx="11064240" cy="914400"/>
+          </a:xfrm>
+          <a:prstGeom prst="rect">
+            <a:avLst/>
+          </a:prstGeom>
+          <a:noFill/>
+          <a:ln/>
+        </p:spPr>
+        <p:txBody>
+          <a:bodyPr wrap="square" lIns="0" tIns="0" rIns="0" bIns="0" rtlCol="0" anchor="t"/>
+          <a:lstStyle/>
+          <a:p>
+            <a:pPr indent="0" marL="0">
+              <a:buNone/>
+            </a:pPr>
+            <a:r>
+              <a:rPr lang="en-US" sz="2600" b="1" dirty="0">
+                <a:solidFill>
+                  <a:srgbClr val="051C2C"/>
+                </a:solidFill>
+                <a:latin typeface="Georgia" pitchFamily="34" charset="0"/>
+                <a:ea typeface="Georgia" pitchFamily="34" charset="-122"/>
+                <a:cs typeface="Georgia" pitchFamily="34" charset="-120"/>
+              </a:rPr>
+              <a:t>Gemini’s free tier is now the bottleneck: when the main model is busy, checks fall back to a model capped at 20 requests a day</a:t>
+            </a:r>
+            <a:endParaRPr lang="en-US" sz="2600" dirty="0"/>
+          </a:p>
+        </p:txBody>
+      </p:sp>
+      <p:sp>
+        <p:nvSpPr>
+          <p:cNvPr id="4" name="Text 2"/>
+          <p:cNvSpPr txBox="1"/>
+          <p:nvPr/>
+        </p:nvSpPr>
+        <p:spPr>
+          <a:xfrm>
+            <a:off x="548640" y="6400800"/>
+            <a:ext cx="10058400" cy="228600"/>
+          </a:xfrm>
+          <a:prstGeom prst="rect">
+            <a:avLst/>
+          </a:prstGeom>
+          <a:noFill/>
+          <a:ln/>
+        </p:spPr>
+        <p:txBody>
+          <a:bodyPr wrap="square" lIns="0" tIns="0" rIns="0" bIns="0" rtlCol="0" anchor="t"/>
+          <a:lstStyle/>
+          <a:p>
+            <a:pPr indent="0" marL="0">
+              <a:buNone/>
+            </a:pPr>
+            <a:r>
+              <a:rPr lang="en-US" sz="900" dirty="0">
+                <a:solidFill>
+                  <a:srgbClr val="6B7280"/>
+                </a:solidFill>
+                <a:latin typeface="Arial" pitchFamily="34" charset="0"/>
+                <a:ea typeface="Arial" pitchFamily="34" charset="-122"/>
+                <a:cs typeface="Arial" pitchFamily="34" charset="-120"/>
+              </a:rPr>
+              <a:t>Source: GitHub Actions logs, WatchAgent Check runs 22–23 Sep 2026; Google quota GenerateRequestsPerDayPerProjectPerModel-FreeTier (limit 20)</a:t>
+            </a:r>
+            <a:endParaRPr lang="en-US" sz="900" dirty="0"/>
+          </a:p>
+        </p:txBody>
+      </p:sp>
+      <p:sp>
+        <p:nvSpPr>
+          <p:cNvPr id="5" name="Text 3"/>
+          <p:cNvSpPr txBox="1"/>
+          <p:nvPr/>
+        </p:nvSpPr>
+        <p:spPr>
+          <a:xfrm>
+            <a:off x="11155680" y="6400800"/>
+            <a:ext cx="484632" cy="228600"/>
+          </a:xfrm>
+          <a:prstGeom prst="rect">
+            <a:avLst/>
+          </a:prstGeom>
+          <a:noFill/>
+          <a:ln/>
+        </p:spPr>
+        <p:txBody>
+          <a:bodyPr wrap="square" lIns="0" tIns="0" rIns="0" bIns="0" rtlCol="0" anchor="t"/>
+          <a:lstStyle/>
+          <a:p>
+            <a:pPr algn="r" indent="0" marL="0">
+              <a:buNone/>
+            </a:pPr>
+            <a:r>
+              <a:rPr lang="en-US" sz="900" dirty="0">
+                <a:solidFill>
+                  <a:srgbClr val="6B7280"/>
+                </a:solidFill>
+                <a:latin typeface="Arial" pitchFamily="34" charset="0"/>
+                <a:ea typeface="Arial" pitchFamily="34" charset="-122"/>
+                <a:cs typeface="Arial" pitchFamily="34" charset="-120"/>
+              </a:rPr>
+              <a:t>12</a:t>
+            </a:r>
+            <a:endParaRPr lang="en-US" sz="900" dirty="0"/>
+          </a:p>
+        </p:txBody>
+      </p:sp>
+      <p:sp>
+        <p:nvSpPr>
+          <p:cNvPr id="102" name="Shape 0"/>
+          <p:cNvSpPr/>
+          <p:nvPr/>
+        </p:nvSpPr>
+        <p:spPr>
+          <a:xfrm>
+            <a:off x="548640" y="1691640"/>
+            <a:ext cx="3544824" cy="1783080"/>
+          </a:xfrm>
+          <a:prstGeom prst="rect">
+            <a:avLst/>
+          </a:prstGeom>
+          <a:solidFill>
+            <a:srgbClr val="F2F4F7"/>
+          </a:solidFill>
+          <a:ln w="12700">
+            <a:solidFill>
+              <a:srgbClr val="F2F4F7"/>
+            </a:solidFill>
+            <a:prstDash val="solid"/>
+          </a:ln>
+        </p:spPr>
+      </p:sp>
+      <p:sp>
+        <p:nvSpPr>
+          <p:cNvPr id="103" name="Text 1"/>
+          <p:cNvSpPr txBox="1"/>
+          <p:nvPr/>
+        </p:nvSpPr>
+        <p:spPr>
+          <a:xfrm>
+            <a:off x="777240" y="1828800"/>
+            <a:ext cx="3087624" cy="548640"/>
+          </a:xfrm>
+          <a:prstGeom prst="rect">
+            <a:avLst/>
+          </a:prstGeom>
+          <a:noFill/>
+          <a:ln/>
+        </p:spPr>
+        <p:txBody>
+          <a:bodyPr wrap="square" lIns="0" tIns="0" rIns="0" bIns="0" rtlCol="0" anchor="t"/>
+          <a:lstStyle/>
+          <a:p>
+            <a:pPr indent="0" marL="0">
+              <a:buNone/>
+            </a:pPr>
+            <a:r>
+              <a:rPr lang="en-US" sz="3200" b="1" dirty="0">
+                <a:solidFill>
+                  <a:srgbClr val="2251FF"/>
+                </a:solidFill>
+                <a:latin typeface="Georgia" pitchFamily="34" charset="0"/>
+                <a:ea typeface="Georgia" pitchFamily="34" charset="-122"/>
+                <a:cs typeface="Georgia" pitchFamily="34" charset="-120"/>
+              </a:rPr>
+              <a:t>10 of 20</a:t>
+            </a:r>
+            <a:endParaRPr lang="en-US" sz="3200" dirty="0"/>
+          </a:p>
+        </p:txBody>
+      </p:sp>
+      <p:sp>
+        <p:nvSpPr>
+          <p:cNvPr id="104" name="Text 2"/>
+          <p:cNvSpPr txBox="1"/>
+          <p:nvPr/>
+        </p:nvSpPr>
+        <p:spPr>
+          <a:xfrm>
+            <a:off x="777240" y="2395728"/>
+            <a:ext cx="3087624" cy="256032"/>
+          </a:xfrm>
+          <a:prstGeom prst="rect">
+            <a:avLst/>
+          </a:prstGeom>
+          <a:noFill/>
+          <a:ln/>
+        </p:spPr>
+        <p:txBody>
+          <a:bodyPr wrap="square" lIns="0" tIns="0" rIns="0" bIns="0" rtlCol="0" anchor="t"/>
+          <a:lstStyle/>
+          <a:p>
+            <a:pPr indent="0" marL="0">
+              <a:buNone/>
+            </a:pPr>
+            <a:r>
+              <a:rPr lang="en-US" sz="1200" b="1" dirty="0">
+                <a:solidFill>
+                  <a:srgbClr val="051C2C"/>
+                </a:solidFill>
+                <a:latin typeface="Arial" pitchFamily="34" charset="0"/>
+                <a:ea typeface="Arial" pitchFamily="34" charset="-122"/>
+                <a:cs typeface="Arial" pitchFamily="34" charset="-120"/>
+              </a:rPr>
+              <a:t>checks failed on quota</a:t>
+            </a:r>
+            <a:endParaRPr lang="en-US" sz="1200" dirty="0"/>
+          </a:p>
+        </p:txBody>
+      </p:sp>
+      <p:sp>
+        <p:nvSpPr>
+          <p:cNvPr id="105" name="Text 3"/>
+          <p:cNvSpPr txBox="1"/>
+          <p:nvPr/>
+        </p:nvSpPr>
+        <p:spPr>
+          <a:xfrm>
+            <a:off x="777240" y="2697480"/>
+            <a:ext cx="3087624" cy="731520"/>
+          </a:xfrm>
+          <a:prstGeom prst="rect">
+            <a:avLst/>
+          </a:prstGeom>
+          <a:noFill/>
+          <a:ln/>
+        </p:spPr>
+        <p:txBody>
+          <a:bodyPr wrap="square" lIns="0" tIns="0" rIns="0" bIns="0" rtlCol="0" anchor="t"/>
+          <a:lstStyle/>
+          <a:p>
+            <a:pPr indent="0" marL="0">
+              <a:buNone/>
+            </a:pPr>
+            <a:r>
+              <a:rPr lang="en-US" sz="1100" dirty="0">
+                <a:solidFill>
+                  <a:srgbClr val="1F2933"/>
+                </a:solidFill>
+                <a:latin typeface="Arial" pitchFamily="34" charset="0"/>
+                <a:ea typeface="Arial" pitchFamily="34" charset="-122"/>
+                <a:cs typeface="Arial" pitchFamily="34" charset="-120"/>
+              </a:rPr>
+              <a:t>In the last two scheduled runs the backup model hit its daily limit; 4 more checks found no usable listing.</a:t>
+            </a:r>
+            <a:endParaRPr lang="en-US" sz="1100" dirty="0"/>
+          </a:p>
+        </p:txBody>
+      </p:sp>
+      <p:sp>
+        <p:nvSpPr>
+          <p:cNvPr id="106" name="Shape 4"/>
+          <p:cNvSpPr/>
+          <p:nvPr/>
+        </p:nvSpPr>
+        <p:spPr>
+          <a:xfrm>
+            <a:off x="4322064" y="1691640"/>
+            <a:ext cx="3544824" cy="1783080"/>
+          </a:xfrm>
+          <a:prstGeom prst="rect">
+            <a:avLst/>
+          </a:prstGeom>
+          <a:solidFill>
+            <a:srgbClr val="F2F4F7"/>
+          </a:solidFill>
+          <a:ln w="12700">
+            <a:solidFill>
+              <a:srgbClr val="F2F4F7"/>
+            </a:solidFill>
+            <a:prstDash val="solid"/>
+          </a:ln>
+        </p:spPr>
+      </p:sp>
+      <p:sp>
+        <p:nvSpPr>
+          <p:cNvPr id="107" name="Text 5"/>
+          <p:cNvSpPr txBox="1"/>
+          <p:nvPr/>
+        </p:nvSpPr>
+        <p:spPr>
+          <a:xfrm>
+            <a:off x="4550664" y="1828800"/>
+            <a:ext cx="3087624" cy="548640"/>
+          </a:xfrm>
+          <a:prstGeom prst="rect">
+            <a:avLst/>
+          </a:prstGeom>
+          <a:noFill/>
+          <a:ln/>
+        </p:spPr>
+        <p:txBody>
+          <a:bodyPr wrap="square" lIns="0" tIns="0" rIns="0" bIns="0" rtlCol="0" anchor="t"/>
+          <a:lstStyle/>
+          <a:p>
+            <a:pPr indent="0" marL="0">
+              <a:buNone/>
+            </a:pPr>
+            <a:r>
+              <a:rPr lang="en-US" sz="3200" b="1" dirty="0">
+                <a:solidFill>
+                  <a:srgbClr val="2251FF"/>
+                </a:solidFill>
+                <a:latin typeface="Georgia" pitchFamily="34" charset="0"/>
+                <a:ea typeface="Georgia" pitchFamily="34" charset="-122"/>
+                <a:cs typeface="Georgia" pitchFamily="34" charset="-120"/>
+              </a:rPr>
+              <a:t>20 a day</a:t>
+            </a:r>
+            <a:endParaRPr lang="en-US" sz="3200" dirty="0"/>
+          </a:p>
+        </p:txBody>
+      </p:sp>
+      <p:sp>
+        <p:nvSpPr>
+          <p:cNvPr id="108" name="Text 6"/>
+          <p:cNvSpPr txBox="1"/>
+          <p:nvPr/>
+        </p:nvSpPr>
+        <p:spPr>
+          <a:xfrm>
+            <a:off x="4550664" y="2395728"/>
+            <a:ext cx="3087624" cy="256032"/>
+          </a:xfrm>
+          <a:prstGeom prst="rect">
+            <a:avLst/>
+          </a:prstGeom>
+          <a:noFill/>
+          <a:ln/>
+        </p:spPr>
+        <p:txBody>
+          <a:bodyPr wrap="square" lIns="0" tIns="0" rIns="0" bIns="0" rtlCol="0" anchor="t"/>
+          <a:lstStyle/>
+          <a:p>
+            <a:pPr indent="0" marL="0">
+              <a:buNone/>
+            </a:pPr>
+            <a:r>
+              <a:rPr lang="en-US" sz="1200" b="1" dirty="0">
+                <a:solidFill>
+                  <a:srgbClr val="051C2C"/>
+                </a:solidFill>
+                <a:latin typeface="Arial" pitchFamily="34" charset="0"/>
+                <a:ea typeface="Arial" pitchFamily="34" charset="-122"/>
+                <a:cs typeface="Arial" pitchFamily="34" charset="-120"/>
+              </a:rPr>
+              <a:t>free limit on the backup model</a:t>
+            </a:r>
+            <a:endParaRPr lang="en-US" sz="1200" dirty="0"/>
+          </a:p>
+        </p:txBody>
+      </p:sp>
+      <p:sp>
+        <p:nvSpPr>
+          <p:cNvPr id="109" name="Text 7"/>
+          <p:cNvSpPr txBox="1"/>
+          <p:nvPr/>
+        </p:nvSpPr>
+        <p:spPr>
+          <a:xfrm>
+            <a:off x="4550664" y="2697480"/>
+            <a:ext cx="3087624" cy="731520"/>
+          </a:xfrm>
+          <a:prstGeom prst="rect">
+            <a:avLst/>
+          </a:prstGeom>
+          <a:noFill/>
+          <a:ln/>
+        </p:spPr>
+        <p:txBody>
+          <a:bodyPr wrap="square" lIns="0" tIns="0" rIns="0" bIns="0" rtlCol="0" anchor="t"/>
+          <a:lstStyle/>
+          <a:p>
+            <a:pPr indent="0" marL="0">
+              <a:buNone/>
+            </a:pPr>
+            <a:r>
+              <a:rPr lang="en-US" sz="1100" dirty="0">
+                <a:solidFill>
+                  <a:srgbClr val="1F2933"/>
+                </a:solidFill>
+                <a:latin typeface="Arial" pitchFamily="34" charset="0"/>
+                <a:ea typeface="Arial" pitchFamily="34" charset="-122"/>
+                <a:cs typeface="Arial" pitchFamily="34" charset="-120"/>
+              </a:rPr>
+              <a:t>gemini-3.5-flash allows 20 requests a day for free, and one watch check needs 5 to 8.</a:t>
+            </a:r>
+            <a:endParaRPr lang="en-US" sz="1100" dirty="0"/>
+          </a:p>
+        </p:txBody>
+      </p:sp>
+      <p:sp>
+        <p:nvSpPr>
+          <p:cNvPr id="110" name="Shape 8"/>
+          <p:cNvSpPr/>
+          <p:nvPr/>
+        </p:nvSpPr>
+        <p:spPr>
+          <a:xfrm>
+            <a:off x="8095488" y="1691640"/>
+            <a:ext cx="3544824" cy="1783080"/>
+          </a:xfrm>
+          <a:prstGeom prst="rect">
+            <a:avLst/>
+          </a:prstGeom>
+          <a:solidFill>
+            <a:srgbClr val="F2F4F7"/>
+          </a:solidFill>
+          <a:ln w="12700">
+            <a:solidFill>
+              <a:srgbClr val="F2F4F7"/>
+            </a:solidFill>
+            <a:prstDash val="solid"/>
+          </a:ln>
+        </p:spPr>
+      </p:sp>
+      <p:sp>
+        <p:nvSpPr>
+          <p:cNvPr id="111" name="Text 9"/>
+          <p:cNvSpPr txBox="1"/>
+          <p:nvPr/>
+        </p:nvSpPr>
+        <p:spPr>
+          <a:xfrm>
+            <a:off x="8324088" y="1828800"/>
+            <a:ext cx="3087624" cy="548640"/>
+          </a:xfrm>
+          <a:prstGeom prst="rect">
+            <a:avLst/>
+          </a:prstGeom>
+          <a:noFill/>
+          <a:ln/>
+        </p:spPr>
+        <p:txBody>
+          <a:bodyPr wrap="square" lIns="0" tIns="0" rIns="0" bIns="0" rtlCol="0" anchor="t"/>
+          <a:lstStyle/>
+          <a:p>
+            <a:pPr indent="0" marL="0">
+              <a:buNone/>
+            </a:pPr>
+            <a:r>
+              <a:rPr lang="en-US" sz="3200" b="1" dirty="0">
+                <a:solidFill>
+                  <a:srgbClr val="2251FF"/>
+                </a:solidFill>
+                <a:latin typeface="Georgia" pitchFamily="34" charset="0"/>
+                <a:ea typeface="Georgia" pitchFamily="34" charset="-122"/>
+                <a:cs typeface="Georgia" pitchFamily="34" charset="-120"/>
+              </a:rPr>
+              <a:t>40–60 s</a:t>
+            </a:r>
+            <a:endParaRPr lang="en-US" sz="3200" dirty="0"/>
+          </a:p>
+        </p:txBody>
+      </p:sp>
+      <p:sp>
+        <p:nvSpPr>
+          <p:cNvPr id="112" name="Text 10"/>
+          <p:cNvSpPr txBox="1"/>
+          <p:nvPr/>
+        </p:nvSpPr>
+        <p:spPr>
+          <a:xfrm>
+            <a:off x="8324088" y="2395728"/>
+            <a:ext cx="3087624" cy="256032"/>
+          </a:xfrm>
+          <a:prstGeom prst="rect">
+            <a:avLst/>
+          </a:prstGeom>
+          <a:noFill/>
+          <a:ln/>
+        </p:spPr>
+        <p:txBody>
+          <a:bodyPr wrap="square" lIns="0" tIns="0" rIns="0" bIns="0" rtlCol="0" anchor="t"/>
+          <a:lstStyle/>
+          <a:p>
+            <a:pPr indent="0" marL="0">
+              <a:buNone/>
+            </a:pPr>
+            <a:r>
+              <a:rPr lang="en-US" sz="1200" b="1" dirty="0">
+                <a:solidFill>
+                  <a:srgbClr val="051C2C"/>
+                </a:solidFill>
+                <a:latin typeface="Arial" pitchFamily="34" charset="0"/>
+                <a:ea typeface="Arial" pitchFamily="34" charset="-122"/>
+                <a:cs typeface="Arial" pitchFamily="34" charset="-120"/>
+              </a:rPr>
+              <a:t>per AI call when busy</a:t>
+            </a:r>
+            <a:endParaRPr lang="en-US" sz="1200" dirty="0"/>
+          </a:p>
+        </p:txBody>
+      </p:sp>
+      <p:sp>
+        <p:nvSpPr>
+          <p:cNvPr id="113" name="Text 11"/>
+          <p:cNvSpPr txBox="1"/>
+          <p:nvPr/>
+        </p:nvSpPr>
+        <p:spPr>
+          <a:xfrm>
+            <a:off x="8324088" y="2697480"/>
+            <a:ext cx="3087624" cy="731520"/>
+          </a:xfrm>
+          <a:prstGeom prst="rect">
+            <a:avLst/>
+          </a:prstGeom>
+          <a:noFill/>
+          <a:ln/>
+        </p:spPr>
+        <p:txBody>
+          <a:bodyPr wrap="square" lIns="0" tIns="0" rIns="0" bIns="0" rtlCol="0" anchor="t"/>
+          <a:lstStyle/>
+          <a:p>
+            <a:pPr indent="0" marL="0">
+              <a:buNone/>
+            </a:pPr>
+            <a:r>
+              <a:rPr lang="en-US" sz="1100" dirty="0">
+                <a:solidFill>
+                  <a:srgbClr val="1F2933"/>
+                </a:solidFill>
+                <a:latin typeface="Arial" pitchFamily="34" charset="0"/>
+                <a:ea typeface="Arial" pitchFamily="34" charset="-122"/>
+                <a:cs typeface="Arial" pitchFamily="34" charset="-120"/>
+              </a:rPr>
+              <a:t>The main model (flash-lite) was overloaded most of the week, so one watch took about 4 minutes.</a:t>
+            </a:r>
+            <a:endParaRPr lang="en-US" sz="1100" dirty="0"/>
+          </a:p>
+        </p:txBody>
+      </p:sp>
+      <p:sp>
+        <p:nvSpPr>
+          <p:cNvPr id="114" name="Shape 12"/>
+          <p:cNvSpPr/>
+          <p:nvPr/>
+        </p:nvSpPr>
+        <p:spPr>
+          <a:xfrm>
+            <a:off x="548640" y="3703320"/>
+            <a:ext cx="5431536" cy="2423160"/>
+          </a:xfrm>
+          <a:prstGeom prst="rect">
+            <a:avLst/>
+          </a:prstGeom>
+          <a:solidFill>
+            <a:srgbClr val="F2F4F7"/>
+          </a:solidFill>
+          <a:ln w="12700">
+            <a:solidFill>
+              <a:srgbClr val="F2F4F7"/>
+            </a:solidFill>
+            <a:prstDash val="solid"/>
+          </a:ln>
+        </p:spPr>
+      </p:sp>
+      <p:sp>
+        <p:nvSpPr>
+          <p:cNvPr id="115" name="Text 13"/>
+          <p:cNvSpPr txBox="1"/>
+          <p:nvPr/>
+        </p:nvSpPr>
+        <p:spPr>
+          <a:xfrm>
+            <a:off x="777240" y="3886200"/>
+            <a:ext cx="4974336" cy="320040"/>
+          </a:xfrm>
+          <a:prstGeom prst="rect">
+            <a:avLst/>
+          </a:prstGeom>
+          <a:noFill/>
+          <a:ln/>
+        </p:spPr>
+        <p:txBody>
+          <a:bodyPr wrap="square" lIns="0" tIns="0" rIns="0" bIns="0" rtlCol="0" anchor="t"/>
+          <a:lstStyle/>
+          <a:p>
+            <a:pPr indent="0" marL="0">
+              <a:buNone/>
+            </a:pPr>
+            <a:r>
+              <a:rPr lang="en-US" sz="1600" b="1" dirty="0">
+                <a:solidFill>
+                  <a:srgbClr val="051C2C"/>
+                </a:solidFill>
+                <a:latin typeface="Georgia" pitchFamily="34" charset="0"/>
+                <a:ea typeface="Georgia" pitchFamily="34" charset="-122"/>
+                <a:cs typeface="Georgia" pitchFamily="34" charset="-120"/>
+              </a:rPr>
+              <a:t>What you notice</a:t>
+            </a:r>
+            <a:endParaRPr lang="en-US" sz="1600" dirty="0"/>
+          </a:p>
+        </p:txBody>
+      </p:sp>
+      <p:sp>
+        <p:nvSpPr>
+          <p:cNvPr id="116" name="Shape 14"/>
+          <p:cNvSpPr/>
+          <p:nvPr/>
+        </p:nvSpPr>
+        <p:spPr>
+          <a:xfrm>
+            <a:off x="777240" y="4416552"/>
+            <a:ext cx="82296" cy="82296"/>
+          </a:xfrm>
+          <a:prstGeom prst="ellipse">
+            <a:avLst/>
+          </a:prstGeom>
+          <a:solidFill>
+            <a:srgbClr val="2251FF"/>
+          </a:solidFill>
+          <a:ln w="12700">
+            <a:solidFill>
+              <a:srgbClr val="2251FF"/>
+            </a:solidFill>
+            <a:prstDash val="solid"/>
+          </a:ln>
+        </p:spPr>
+      </p:sp>
+      <p:sp>
+        <p:nvSpPr>
+          <p:cNvPr id="117" name="Text 15"/>
+          <p:cNvSpPr txBox="1"/>
+          <p:nvPr/>
+        </p:nvSpPr>
+        <p:spPr>
+          <a:xfrm>
+            <a:off x="987552" y="4343400"/>
+            <a:ext cx="4764024" cy="502920"/>
+          </a:xfrm>
+          <a:prstGeom prst="rect">
+            <a:avLst/>
+          </a:prstGeom>
+          <a:noFill/>
+          <a:ln/>
+        </p:spPr>
+        <p:txBody>
+          <a:bodyPr wrap="square" lIns="0" tIns="0" rIns="0" bIns="0" rtlCol="0" anchor="t"/>
+          <a:lstStyle/>
+          <a:p>
+            <a:pPr indent="0" marL="0">
+              <a:buNone/>
+            </a:pPr>
+            <a:r>
+              <a:rPr lang="en-US" sz="1200" dirty="0">
+                <a:solidFill>
+                  <a:srgbClr val="1F2933"/>
+                </a:solidFill>
+                <a:latin typeface="Arial" pitchFamily="34" charset="0"/>
+                <a:ea typeface="Arial" pitchFamily="34" charset="-122"/>
+                <a:cs typeface="Arial" pitchFamily="34" charset="-120"/>
+              </a:rPr>
+              <a:t>Prices for most watches go stale</a:t>
+            </a:r>
+            <a:endParaRPr lang="en-US" sz="1200" dirty="0"/>
+          </a:p>
+        </p:txBody>
+      </p:sp>
+      <p:sp>
+        <p:nvSpPr>
+          <p:cNvPr id="118" name="Shape 16"/>
+          <p:cNvSpPr/>
+          <p:nvPr/>
+        </p:nvSpPr>
+        <p:spPr>
+          <a:xfrm>
+            <a:off x="777240" y="4965192"/>
+            <a:ext cx="82296" cy="82296"/>
+          </a:xfrm>
+          <a:prstGeom prst="ellipse">
+            <a:avLst/>
+          </a:prstGeom>
+          <a:solidFill>
+            <a:srgbClr val="2251FF"/>
+          </a:solidFill>
+          <a:ln w="12700">
+            <a:solidFill>
+              <a:srgbClr val="2251FF"/>
+            </a:solidFill>
+            <a:prstDash val="solid"/>
+          </a:ln>
+        </p:spPr>
+      </p:sp>
+      <p:sp>
+        <p:nvSpPr>
+          <p:cNvPr id="119" name="Text 17"/>
+          <p:cNvSpPr txBox="1"/>
+          <p:nvPr/>
+        </p:nvSpPr>
+        <p:spPr>
+          <a:xfrm>
+            <a:off x="987552" y="4892040"/>
+            <a:ext cx="4764024" cy="502920"/>
+          </a:xfrm>
+          <a:prstGeom prst="rect">
+            <a:avLst/>
+          </a:prstGeom>
+          <a:noFill/>
+          <a:ln/>
+        </p:spPr>
+        <p:txBody>
+          <a:bodyPr wrap="square" lIns="0" tIns="0" rIns="0" bIns="0" rtlCol="0" anchor="t"/>
+          <a:lstStyle/>
+          <a:p>
+            <a:pPr indent="0" marL="0">
+              <a:buNone/>
+            </a:pPr>
+            <a:r>
+              <a:rPr lang="en-US" sz="1200" dirty="0">
+                <a:solidFill>
+                  <a:srgbClr val="1F2933"/>
+                </a:solidFill>
+                <a:latin typeface="Arial" pitchFamily="34" charset="0"/>
+                <a:ea typeface="Arial" pitchFamily="34" charset="-122"/>
+                <a:cs typeface="Arial" pitchFamily="34" charset="-120"/>
+              </a:rPr>
+              <a:t>No BUY alert, even when one might be due</a:t>
+            </a:r>
+            <a:endParaRPr lang="en-US" sz="1200" dirty="0"/>
+          </a:p>
+        </p:txBody>
+      </p:sp>
+      <p:sp>
+        <p:nvSpPr>
+          <p:cNvPr id="120" name="Shape 18"/>
+          <p:cNvSpPr/>
+          <p:nvPr/>
+        </p:nvSpPr>
+        <p:spPr>
+          <a:xfrm>
+            <a:off x="777240" y="5513832"/>
+            <a:ext cx="82296" cy="82296"/>
+          </a:xfrm>
+          <a:prstGeom prst="ellipse">
+            <a:avLst/>
+          </a:prstGeom>
+          <a:solidFill>
+            <a:srgbClr val="2251FF"/>
+          </a:solidFill>
+          <a:ln w="12700">
+            <a:solidFill>
+              <a:srgbClr val="2251FF"/>
+            </a:solidFill>
+            <a:prstDash val="solid"/>
+          </a:ln>
+        </p:spPr>
+      </p:sp>
+      <p:sp>
+        <p:nvSpPr>
+          <p:cNvPr id="121" name="Text 19"/>
+          <p:cNvSpPr txBox="1"/>
+          <p:nvPr/>
+        </p:nvSpPr>
+        <p:spPr>
+          <a:xfrm>
+            <a:off x="987552" y="5440680"/>
+            <a:ext cx="4764024" cy="502920"/>
+          </a:xfrm>
+          <a:prstGeom prst="rect">
+            <a:avLst/>
+          </a:prstGeom>
+          <a:noFill/>
+          <a:ln/>
+        </p:spPr>
+        <p:txBody>
+          <a:bodyPr wrap="square" lIns="0" tIns="0" rIns="0" bIns="0" rtlCol="0" anchor="t"/>
+          <a:lstStyle/>
+          <a:p>
+            <a:pPr indent="0" marL="0">
+              <a:buNone/>
+            </a:pPr>
+            <a:r>
+              <a:rPr lang="en-US" sz="1200" dirty="0">
+                <a:solidFill>
+                  <a:srgbClr val="1F2933"/>
+                </a:solidFill>
+                <a:latin typeface="Arial" pitchFamily="34" charset="0"/>
+                <a:ea typeface="Arial" pitchFamily="34" charset="-122"/>
+                <a:cs typeface="Arial" pitchFamily="34" charset="-120"/>
+              </a:rPr>
+              <a:t>Failures never reach Telegram, so silence looks the same as “nothing worth buying”</a:t>
+            </a:r>
+            <a:endParaRPr lang="en-US" sz="1200" dirty="0"/>
+          </a:p>
+        </p:txBody>
+      </p:sp>
+      <p:sp>
+        <p:nvSpPr>
+          <p:cNvPr id="122" name="Shape 20"/>
+          <p:cNvSpPr/>
+          <p:nvPr/>
+        </p:nvSpPr>
+        <p:spPr>
+          <a:xfrm>
+            <a:off x="6208776" y="3703320"/>
+            <a:ext cx="5431536" cy="2423160"/>
+          </a:xfrm>
+          <a:prstGeom prst="rect">
+            <a:avLst/>
+          </a:prstGeom>
+          <a:solidFill>
+            <a:srgbClr val="051C2C"/>
+          </a:solidFill>
+          <a:ln w="12700">
+            <a:solidFill>
+              <a:srgbClr val="051C2C"/>
+            </a:solidFill>
+            <a:prstDash val="solid"/>
+          </a:ln>
+        </p:spPr>
+      </p:sp>
+      <p:sp>
+        <p:nvSpPr>
+          <p:cNvPr id="123" name="Text 21"/>
+          <p:cNvSpPr txBox="1"/>
+          <p:nvPr/>
+        </p:nvSpPr>
+        <p:spPr>
+          <a:xfrm>
+            <a:off x="6437376" y="3886200"/>
+            <a:ext cx="4974336" cy="320040"/>
+          </a:xfrm>
+          <a:prstGeom prst="rect">
+            <a:avLst/>
+          </a:prstGeom>
+          <a:noFill/>
+          <a:ln/>
+        </p:spPr>
+        <p:txBody>
+          <a:bodyPr wrap="square" lIns="0" tIns="0" rIns="0" bIns="0" rtlCol="0" anchor="t"/>
+          <a:lstStyle/>
+          <a:p>
+            <a:pPr indent="0" marL="0">
+              <a:buNone/>
+            </a:pPr>
+            <a:r>
+              <a:rPr lang="en-US" sz="1600" b="1" dirty="0">
+                <a:solidFill>
+                  <a:srgbClr val="FFFFFF"/>
+                </a:solidFill>
+                <a:latin typeface="Georgia" pitchFamily="34" charset="0"/>
+                <a:ea typeface="Georgia" pitchFamily="34" charset="-122"/>
+                <a:cs typeface="Georgia" pitchFamily="34" charset="-120"/>
+              </a:rPr>
+              <a:t>Options</a:t>
+            </a:r>
+            <a:endParaRPr lang="en-US" sz="1600" dirty="0"/>
+          </a:p>
+        </p:txBody>
+      </p:sp>
+      <p:sp>
+        <p:nvSpPr>
+          <p:cNvPr id="124" name="Shape 22"/>
+          <p:cNvSpPr/>
+          <p:nvPr/>
+        </p:nvSpPr>
+        <p:spPr>
+          <a:xfrm>
+            <a:off x="6437376" y="4416552"/>
+            <a:ext cx="82296" cy="82296"/>
+          </a:xfrm>
+          <a:prstGeom prst="ellipse">
+            <a:avLst/>
+          </a:prstGeom>
+          <a:solidFill>
+            <a:srgbClr val="8FB0FF"/>
+          </a:solidFill>
+          <a:ln w="12700">
+            <a:solidFill>
+              <a:srgbClr val="8FB0FF"/>
+            </a:solidFill>
+            <a:prstDash val="solid"/>
+          </a:ln>
+        </p:spPr>
+      </p:sp>
+      <p:sp>
+        <p:nvSpPr>
+          <p:cNvPr id="125" name="Text 23"/>
+          <p:cNvSpPr txBox="1"/>
+          <p:nvPr/>
+        </p:nvSpPr>
+        <p:spPr>
+          <a:xfrm>
+            <a:off x="6647688" y="4343400"/>
+            <a:ext cx="4764024" cy="411480"/>
+          </a:xfrm>
+          <a:prstGeom prst="rect">
+            <a:avLst/>
+          </a:prstGeom>
+          <a:noFill/>
+          <a:ln/>
+        </p:spPr>
+        <p:txBody>
+          <a:bodyPr wrap="square" lIns="0" tIns="0" rIns="0" bIns="0" rtlCol="0" anchor="t"/>
+          <a:lstStyle/>
+          <a:p>
+            <a:pPr indent="0" marL="0">
+              <a:buNone/>
+            </a:pPr>
+            <a:r>
+              <a:rPr lang="en-US" sz="1200" dirty="0">
+                <a:solidFill>
+                  <a:srgbClr val="DDE6FA"/>
+                </a:solidFill>
+                <a:latin typeface="Arial" pitchFamily="34" charset="0"/>
+                <a:ea typeface="Arial" pitchFamily="34" charset="-122"/>
+                <a:cs typeface="Arial" pitchFamily="34" charset="-120"/>
+              </a:rPr>
+              <a:t>Pay for capacity: Gemini’s paid tier or Claude Haiku (~$12/month)</a:t>
+            </a:r>
+            <a:endParaRPr lang="en-US" sz="1200" dirty="0"/>
+          </a:p>
+        </p:txBody>
+      </p:sp>
+      <p:sp>
+        <p:nvSpPr>
+          <p:cNvPr id="126" name="Shape 24"/>
+          <p:cNvSpPr/>
+          <p:nvPr/>
+        </p:nvSpPr>
+        <p:spPr>
+          <a:xfrm>
+            <a:off x="6437376" y="4873752"/>
+            <a:ext cx="82296" cy="82296"/>
+          </a:xfrm>
+          <a:prstGeom prst="ellipse">
+            <a:avLst/>
+          </a:prstGeom>
+          <a:solidFill>
+            <a:srgbClr val="8FB0FF"/>
+          </a:solidFill>
+          <a:ln w="12700">
+            <a:solidFill>
+              <a:srgbClr val="8FB0FF"/>
+            </a:solidFill>
+            <a:prstDash val="solid"/>
+          </a:ln>
+        </p:spPr>
+      </p:sp>
+      <p:sp>
+        <p:nvSpPr>
+          <p:cNvPr id="127" name="Text 25"/>
+          <p:cNvSpPr txBox="1"/>
+          <p:nvPr/>
+        </p:nvSpPr>
+        <p:spPr>
+          <a:xfrm>
+            <a:off x="6647688" y="4800600"/>
+            <a:ext cx="4764024" cy="411480"/>
+          </a:xfrm>
+          <a:prstGeom prst="rect">
+            <a:avLst/>
+          </a:prstGeom>
+          <a:noFill/>
+          <a:ln/>
+        </p:spPr>
+        <p:txBody>
+          <a:bodyPr wrap="square" lIns="0" tIns="0" rIns="0" bIns="0" rtlCol="0" anchor="t"/>
+          <a:lstStyle/>
+          <a:p>
+            <a:pPr indent="0" marL="0">
+              <a:buNone/>
+            </a:pPr>
+            <a:r>
+              <a:rPr lang="en-US" sz="1200" dirty="0">
+                <a:solidFill>
+                  <a:srgbClr val="DDE6FA"/>
+                </a:solidFill>
+                <a:latin typeface="Arial" pitchFamily="34" charset="0"/>
+                <a:ea typeface="Arial" pitchFamily="34" charset="-122"/>
+                <a:cs typeface="Arial" pitchFamily="34" charset="-120"/>
+              </a:rPr>
+              <a:t>Swap the backup for a model with its own free quota</a:t>
+            </a:r>
+            <a:endParaRPr lang="en-US" sz="1200" dirty="0"/>
+          </a:p>
+        </p:txBody>
+      </p:sp>
+      <p:sp>
+        <p:nvSpPr>
+          <p:cNvPr id="128" name="Shape 26"/>
+          <p:cNvSpPr/>
+          <p:nvPr/>
+        </p:nvSpPr>
+        <p:spPr>
+          <a:xfrm>
+            <a:off x="6437376" y="5330952"/>
+            <a:ext cx="82296" cy="82296"/>
+          </a:xfrm>
+          <a:prstGeom prst="ellipse">
+            <a:avLst/>
+          </a:prstGeom>
+          <a:solidFill>
+            <a:srgbClr val="8FB0FF"/>
+          </a:solidFill>
+          <a:ln w="12700">
+            <a:solidFill>
+              <a:srgbClr val="8FB0FF"/>
+            </a:solidFill>
+            <a:prstDash val="solid"/>
+          </a:ln>
+        </p:spPr>
+      </p:sp>
+      <p:sp>
+        <p:nvSpPr>
+          <p:cNvPr id="129" name="Text 27"/>
+          <p:cNvSpPr txBox="1"/>
+          <p:nvPr/>
+        </p:nvSpPr>
+        <p:spPr>
+          <a:xfrm>
+            <a:off x="6647688" y="5257800"/>
+            <a:ext cx="4764024" cy="411480"/>
+          </a:xfrm>
+          <a:prstGeom prst="rect">
+            <a:avLst/>
+          </a:prstGeom>
+          <a:noFill/>
+          <a:ln/>
+        </p:spPr>
+        <p:txBody>
+          <a:bodyPr wrap="square" lIns="0" tIns="0" rIns="0" bIns="0" rtlCol="0" anchor="t"/>
+          <a:lstStyle/>
+          <a:p>
+            <a:pPr indent="0" marL="0">
+              <a:buNone/>
+            </a:pPr>
+            <a:r>
+              <a:rPr lang="en-US" sz="1200" dirty="0">
+                <a:solidFill>
+                  <a:srgbClr val="DDE6FA"/>
+                </a:solidFill>
+                <a:latin typeface="Arial" pitchFamily="34" charset="0"/>
+                <a:ea typeface="Arial" pitchFamily="34" charset="-122"/>
+                <a:cs typeface="Arial" pitchFamily="34" charset="-120"/>
+              </a:rPr>
+              <a:t>Check fewer watches, or less often</a:t>
+            </a:r>
+            <a:endParaRPr lang="en-US" sz="1200" dirty="0"/>
+          </a:p>
+        </p:txBody>
+      </p:sp>
+      <p:sp>
+        <p:nvSpPr>
+          <p:cNvPr id="130" name="Shape 28"/>
+          <p:cNvSpPr/>
+          <p:nvPr/>
+        </p:nvSpPr>
+        <p:spPr>
+          <a:xfrm>
+            <a:off x="6437376" y="5788152"/>
+            <a:ext cx="82296" cy="82296"/>
+          </a:xfrm>
+          <a:prstGeom prst="ellipse">
+            <a:avLst/>
+          </a:prstGeom>
+          <a:solidFill>
+            <a:srgbClr val="8FB0FF"/>
+          </a:solidFill>
+          <a:ln w="12700">
+            <a:solidFill>
+              <a:srgbClr val="8FB0FF"/>
+            </a:solidFill>
+            <a:prstDash val="solid"/>
+          </a:ln>
+        </p:spPr>
+      </p:sp>
+      <p:sp>
+        <p:nvSpPr>
+          <p:cNvPr id="131" name="Text 29"/>
+          <p:cNvSpPr txBox="1"/>
+          <p:nvPr/>
+        </p:nvSpPr>
+        <p:spPr>
+          <a:xfrm>
+            <a:off x="6647688" y="5715000"/>
+            <a:ext cx="4764024" cy="411480"/>
+          </a:xfrm>
+          <a:prstGeom prst="rect">
+            <a:avLst/>
+          </a:prstGeom>
+          <a:noFill/>
+          <a:ln/>
+        </p:spPr>
+        <p:txBody>
+          <a:bodyPr wrap="square" lIns="0" tIns="0" rIns="0" bIns="0" rtlCol="0" anchor="t"/>
+          <a:lstStyle/>
+          <a:p>
+            <a:pPr indent="0" marL="0">
+              <a:buNone/>
+            </a:pPr>
+            <a:r>
+              <a:rPr lang="en-US" sz="1200" dirty="0">
+                <a:solidFill>
+                  <a:srgbClr val="DDE6FA"/>
+                </a:solidFill>
+                <a:latin typeface="Arial" pitchFamily="34" charset="0"/>
+                <a:ea typeface="Arial" pitchFamily="34" charset="-122"/>
+                <a:cs typeface="Arial" pitchFamily="34" charset="-120"/>
+              </a:rPr>
+              <a:t>Send a short Telegram summary after every run, failures included</a:t>
+            </a:r>
+            <a:endParaRPr lang="en-US" sz="1200" dirty="0"/>
+          </a:p>
+        </p:txBody>
+      </p:sp>
+    </p:spTree>
+  </p:cSld>
+  <p:clrMapOvr>
+    <a:masterClrMapping/>
+  </p:clrMapOvr>
+</p:sld>
+</file>
+
 <file path=ppt/slides/slide2.xml><?xml version="1.0" encoding="utf-8"?>
 <p:sld xmlns:a="http://schemas.openxmlformats.org/drawingml/2006/main" xmlns:r="http://schemas.openxmlformats.org/officeDocument/2006/relationships" xmlns:p="http://schemas.openxmlformats.org/presentationml/2006/main">
   <p:cSld name="Slide 2">
@@ -13440,7 +14719,7 @@
                 <a:ea typeface="Arial" pitchFamily="34" charset="-122"/>
                 <a:cs typeface="Arial" pitchFamily="34" charset="-120"/>
               </a:rPr>
-              <a:t>12</a:t>
+              <a:t>13</a:t>
             </a:r>
             <a:endParaRPr lang="en-US" sz="900" dirty="0"/>
           </a:p>
@@ -14544,7 +15823,7 @@
                 <a:ea typeface="Arial" pitchFamily="34" charset="-122"/>
                 <a:cs typeface="Arial" pitchFamily="34" charset="-120"/>
               </a:rPr>
-              <a:t>13</a:t>
+              <a:t>14</a:t>
             </a:r>
             <a:endParaRPr lang="en-US" sz="900" dirty="0"/>
           </a:p>
@@ -15860,7 +17139,7 @@
                 <a:ea typeface="Arial" pitchFamily="34" charset="-122"/>
                 <a:cs typeface="Arial" pitchFamily="34" charset="-120"/>
               </a:rPr>
-              <a:t>14</a:t>
+              <a:t>15</a:t>
             </a:r>
             <a:endParaRPr lang="en-US" sz="900" dirty="0"/>
           </a:p>

</xml_diff>

<commit_message>
Explain cli.py on the 'How each part works' slide
Adds a strip under the five parts describing cli.py as the control panel: the command line GitHub Actions runs (check, bot, add/list). Source line now cites b649964.
</commit_message>
<xml_diff>
--- a/docs/WatchAgent_Agentic_AI_Brownbag.pptx
+++ b/docs/WatchAgent_Agentic_AI_Brownbag.pptx
@@ -1457,7 +1457,7 @@
           <a:p>
             <a:r>
               <a:rPr lang="en-US" dirty="0"/>
-              <a:t>These are the five boxes from the diagram, in plain terms. Three do the work. watchagent check is the scheduler: every six hours it picks the watches that have gone longest without a check, researches three at a time, and sends a Telegram alert when one is a good buy. The research agent is the AI researcher: it searches, opens listings, and keeps handing in what it finds until three listings of the exact watch are accepted. The Telegram assistant is your chat window: it answers questions and can run a fresh check, but it can only suggest changes, and nothing happens until you tap Confirm. Two keep that work honest. The listing checks are plain code, no AI: a price counts only if it is really on the page, for the exact reference, and not far off the others; the middle price is recorded and the verdict is simple arithmetic. The model middleware wraps every AI call: it makes the AI research before answering, retries when the service is busy, switches to a backup model, caps the steps, and keeps a daily limit so the assistant always has requests left.</a:t>
+              <a:t>These are the five boxes from the diagram, in plain terms. Three do the work. watchagent check is the scheduler: every six hours it picks the watches that have gone longest without a check, researches three at a time, and sends a Telegram alert when one is a good buy. The research agent is the AI researcher: it searches, opens listings, and keeps handing in what it finds until three listings of the exact watch are accepted. The Telegram assistant is your chat window: it answers questions and can run a fresh check, but it can only suggest changes, and nothing happens until you tap Confirm. Two keep that work honest. The listing checks are plain code, no AI: a price counts only if it is really on the page, for the exact reference, and not far off the others; the middle price is recorded and the verdict is simple arithmetic. The model middleware wraps every AI call: it makes the AI research before answering, retries when the service is busy, switches to a backup model, caps the steps, and keeps a daily limit so the assistant always has requests left. Underneath all of this is cli.py, the control panel: the command line that starts everything. The check command runs a round and sends the alerts and the summary, the bot command answers Telegram, and add and list manage the watchlist. GitHub Actions simply runs these commands on a schedule.</a:t>
             </a:r>
             <a:endParaRPr lang="en-US" dirty="0"/>
           </a:p>
@@ -7404,7 +7404,7 @@
                 <a:ea typeface="Arial" pitchFamily="34" charset="-122"/>
                 <a:cs typeface="Arial" pitchFamily="34" charset="-120"/>
               </a:rPr>
-              <a:t>Source: watchagent/cli.py, agent.py, bot.py, tools.py (commit 49bd438); names match the architecture diagram</a:t>
+              <a:t>Source: watchagent/cli.py, agent.py, bot.py, tools.py (commit b649964); names match the architecture diagram</a:t>
             </a:r>
             <a:endParaRPr lang="en-US" sz="900" dirty="0"/>
           </a:p>
@@ -7496,8 +7496,8 @@
         </p:nvSpPr>
         <p:spPr>
           <a:xfrm>
-            <a:off x="548640" y="1965960"/>
-            <a:ext cx="3544824" cy="1874520"/>
+            <a:off x="548640" y="1938528"/>
+            <a:ext cx="3544824" cy="1572768"/>
           </a:xfrm>
           <a:prstGeom prst="rect">
             <a:avLst/>
@@ -7521,7 +7521,7 @@
         </p:nvSpPr>
         <p:spPr>
           <a:xfrm>
-            <a:off x="777240" y="2148840"/>
+            <a:off x="777240" y="2084832"/>
             <a:ext cx="3087624" cy="320040"/>
           </a:xfrm>
           <a:prstGeom prst="rect">
@@ -7560,7 +7560,7 @@
         </p:nvSpPr>
         <p:spPr>
           <a:xfrm>
-            <a:off x="777240" y="2496312"/>
+            <a:off x="777240" y="2414016"/>
             <a:ext cx="3087624" cy="228600"/>
           </a:xfrm>
           <a:prstGeom prst="rect">
@@ -7599,8 +7599,8 @@
         </p:nvSpPr>
         <p:spPr>
           <a:xfrm>
-            <a:off x="777240" y="2807208"/>
-            <a:ext cx="3087624" cy="896112"/>
+            <a:off x="777240" y="2688336"/>
+            <a:ext cx="3087624" cy="731520"/>
           </a:xfrm>
           <a:prstGeom prst="rect">
             <a:avLst/>
@@ -7638,8 +7638,8 @@
         </p:nvSpPr>
         <p:spPr>
           <a:xfrm>
-            <a:off x="4322064" y="1965960"/>
-            <a:ext cx="3544824" cy="1874520"/>
+            <a:off x="4322064" y="1938528"/>
+            <a:ext cx="3544824" cy="1572768"/>
           </a:xfrm>
           <a:prstGeom prst="rect">
             <a:avLst/>
@@ -7663,7 +7663,7 @@
         </p:nvSpPr>
         <p:spPr>
           <a:xfrm>
-            <a:off x="4550664" y="2148840"/>
+            <a:off x="4550664" y="2084832"/>
             <a:ext cx="3087624" cy="320040"/>
           </a:xfrm>
           <a:prstGeom prst="rect">
@@ -7702,7 +7702,7 @@
         </p:nvSpPr>
         <p:spPr>
           <a:xfrm>
-            <a:off x="4550664" y="2496312"/>
+            <a:off x="4550664" y="2414016"/>
             <a:ext cx="3087624" cy="228600"/>
           </a:xfrm>
           <a:prstGeom prst="rect">
@@ -7741,8 +7741,8 @@
         </p:nvSpPr>
         <p:spPr>
           <a:xfrm>
-            <a:off x="4550664" y="2807208"/>
-            <a:ext cx="3087624" cy="896112"/>
+            <a:off x="4550664" y="2688336"/>
+            <a:ext cx="3087624" cy="731520"/>
           </a:xfrm>
           <a:prstGeom prst="rect">
             <a:avLst/>
@@ -7780,8 +7780,8 @@
         </p:nvSpPr>
         <p:spPr>
           <a:xfrm>
-            <a:off x="8095488" y="1965960"/>
-            <a:ext cx="3544824" cy="1874520"/>
+            <a:off x="8095488" y="1938528"/>
+            <a:ext cx="3544824" cy="1572768"/>
           </a:xfrm>
           <a:prstGeom prst="rect">
             <a:avLst/>
@@ -7805,7 +7805,7 @@
         </p:nvSpPr>
         <p:spPr>
           <a:xfrm>
-            <a:off x="8324088" y="2148840"/>
+            <a:off x="8324088" y="2084832"/>
             <a:ext cx="3087624" cy="320040"/>
           </a:xfrm>
           <a:prstGeom prst="rect">
@@ -7844,7 +7844,7 @@
         </p:nvSpPr>
         <p:spPr>
           <a:xfrm>
-            <a:off x="8324088" y="2496312"/>
+            <a:off x="8324088" y="2414016"/>
             <a:ext cx="3087624" cy="228600"/>
           </a:xfrm>
           <a:prstGeom prst="rect">
@@ -7883,8 +7883,8 @@
         </p:nvSpPr>
         <p:spPr>
           <a:xfrm>
-            <a:off x="8324088" y="2807208"/>
-            <a:ext cx="3087624" cy="896112"/>
+            <a:off x="8324088" y="2688336"/>
+            <a:ext cx="3087624" cy="731520"/>
           </a:xfrm>
           <a:prstGeom prst="rect">
             <a:avLst/>
@@ -7922,7 +7922,7 @@
         </p:nvSpPr>
         <p:spPr>
           <a:xfrm>
-            <a:off x="548640" y="4023360"/>
+            <a:off x="548640" y="3657600"/>
             <a:ext cx="5486400" cy="228600"/>
           </a:xfrm>
           <a:prstGeom prst="rect">
@@ -7961,8 +7961,8 @@
         </p:nvSpPr>
         <p:spPr>
           <a:xfrm>
-            <a:off x="548640" y="4297680"/>
-            <a:ext cx="5431536" cy="1828800"/>
+            <a:off x="548640" y="3904488"/>
+            <a:ext cx="5431536" cy="1417320"/>
           </a:xfrm>
           <a:prstGeom prst="rect">
             <a:avLst/>
@@ -7986,7 +7986,7 @@
         </p:nvSpPr>
         <p:spPr>
           <a:xfrm>
-            <a:off x="777240" y="4480560"/>
+            <a:off x="777240" y="4050792"/>
             <a:ext cx="4974336" cy="320040"/>
           </a:xfrm>
           <a:prstGeom prst="rect">
@@ -8025,7 +8025,7 @@
         </p:nvSpPr>
         <p:spPr>
           <a:xfrm>
-            <a:off x="777240" y="4828032"/>
+            <a:off x="777240" y="4379976"/>
             <a:ext cx="4974336" cy="228600"/>
           </a:xfrm>
           <a:prstGeom prst="rect">
@@ -8064,8 +8064,8 @@
         </p:nvSpPr>
         <p:spPr>
           <a:xfrm>
-            <a:off x="777240" y="5138928"/>
-            <a:ext cx="4974336" cy="850392"/>
+            <a:off x="777240" y="4654296"/>
+            <a:ext cx="4974336" cy="576072"/>
           </a:xfrm>
           <a:prstGeom prst="rect">
             <a:avLst/>
@@ -8103,8 +8103,8 @@
         </p:nvSpPr>
         <p:spPr>
           <a:xfrm>
-            <a:off x="6208776" y="4297680"/>
-            <a:ext cx="5431536" cy="1828800"/>
+            <a:off x="6208776" y="3904488"/>
+            <a:ext cx="5431536" cy="1417320"/>
           </a:xfrm>
           <a:prstGeom prst="rect">
             <a:avLst/>
@@ -8128,7 +8128,7 @@
         </p:nvSpPr>
         <p:spPr>
           <a:xfrm>
-            <a:off x="6437376" y="4480560"/>
+            <a:off x="6437376" y="4050792"/>
             <a:ext cx="4974336" cy="320040"/>
           </a:xfrm>
           <a:prstGeom prst="rect">
@@ -8167,7 +8167,7 @@
         </p:nvSpPr>
         <p:spPr>
           <a:xfrm>
-            <a:off x="6437376" y="4828032"/>
+            <a:off x="6437376" y="4379976"/>
             <a:ext cx="4974336" cy="228600"/>
           </a:xfrm>
           <a:prstGeom prst="rect">
@@ -8206,8 +8206,8 @@
         </p:nvSpPr>
         <p:spPr>
           <a:xfrm>
-            <a:off x="6437376" y="5138928"/>
-            <a:ext cx="4974336" cy="850392"/>
+            <a:off x="6437376" y="4654296"/>
+            <a:ext cx="4974336" cy="576072"/>
           </a:xfrm>
           <a:prstGeom prst="rect">
             <a:avLst/>
@@ -8232,6 +8232,148 @@
                 <a:cs typeface="Arial" pitchFamily="34" charset="-120"/>
               </a:rPr>
               <a:t>Makes the AI research before it answers, retries when the AI service is busy, switches to a backup model, caps the steps one check can take, and keeps a daily limit so the assistant always has requests left.</a:t>
+            </a:r>
+            <a:endParaRPr lang="en-US" sz="1200" dirty="0"/>
+          </a:p>
+        </p:txBody>
+      </p:sp>
+      <p:sp>
+        <p:nvSpPr>
+          <p:cNvPr id="124" name="Shape 22"/>
+          <p:cNvSpPr/>
+          <p:nvPr/>
+        </p:nvSpPr>
+        <p:spPr>
+          <a:xfrm>
+            <a:off x="548640" y="5458968"/>
+            <a:ext cx="11091672" cy="713232"/>
+          </a:xfrm>
+          <a:prstGeom prst="rect">
+            <a:avLst/>
+          </a:prstGeom>
+          <a:solidFill>
+            <a:srgbClr val="DDE6FA"/>
+          </a:solidFill>
+          <a:ln w="12700">
+            <a:solidFill>
+              <a:srgbClr val="DDE6FA"/>
+            </a:solidFill>
+            <a:prstDash val="solid"/>
+          </a:ln>
+        </p:spPr>
+      </p:sp>
+      <p:sp>
+        <p:nvSpPr>
+          <p:cNvPr id="125" name="Text 23"/>
+          <p:cNvSpPr txBox="1"/>
+          <p:nvPr/>
+        </p:nvSpPr>
+        <p:spPr>
+          <a:xfrm>
+            <a:off x="777240" y="5559552"/>
+            <a:ext cx="2103120" cy="274320"/>
+          </a:xfrm>
+          <a:prstGeom prst="rect">
+            <a:avLst/>
+          </a:prstGeom>
+          <a:noFill/>
+          <a:ln/>
+        </p:spPr>
+        <p:txBody>
+          <a:bodyPr wrap="square" lIns="0" tIns="0" rIns="0" bIns="0" rtlCol="0" anchor="t"/>
+          <a:lstStyle/>
+          <a:p>
+            <a:pPr indent="0" marL="0">
+              <a:buNone/>
+            </a:pPr>
+            <a:r>
+              <a:rPr lang="en-US" sz="1600" b="1" dirty="0">
+                <a:solidFill>
+                  <a:srgbClr val="051C2C"/>
+                </a:solidFill>
+                <a:latin typeface="Georgia" pitchFamily="34" charset="0"/>
+                <a:ea typeface="Georgia" pitchFamily="34" charset="-122"/>
+                <a:cs typeface="Georgia" pitchFamily="34" charset="-120"/>
+              </a:rPr>
+              <a:t>cli.py</a:t>
+            </a:r>
+            <a:endParaRPr lang="en-US" sz="1600" dirty="0"/>
+          </a:p>
+        </p:txBody>
+      </p:sp>
+      <p:sp>
+        <p:nvSpPr>
+          <p:cNvPr id="126" name="Text 24"/>
+          <p:cNvSpPr txBox="1"/>
+          <p:nvPr/>
+        </p:nvSpPr>
+        <p:spPr>
+          <a:xfrm>
+            <a:off x="777240" y="5870448"/>
+            <a:ext cx="2103120" cy="228600"/>
+          </a:xfrm>
+          <a:prstGeom prst="rect">
+            <a:avLst/>
+          </a:prstGeom>
+          <a:noFill/>
+          <a:ln/>
+        </p:spPr>
+        <p:txBody>
+          <a:bodyPr wrap="square" lIns="0" tIns="0" rIns="0" bIns="0" rtlCol="0" anchor="t"/>
+          <a:lstStyle/>
+          <a:p>
+            <a:pPr indent="0" marL="0">
+              <a:buNone/>
+            </a:pPr>
+            <a:r>
+              <a:rPr lang="en-US" sz="1100" b="1" dirty="0">
+                <a:solidFill>
+                  <a:srgbClr val="2251FF"/>
+                </a:solidFill>
+                <a:latin typeface="Arial" pitchFamily="34" charset="0"/>
+                <a:ea typeface="Arial" pitchFamily="34" charset="-122"/>
+                <a:cs typeface="Arial" pitchFamily="34" charset="-120"/>
+              </a:rPr>
+              <a:t>The control panel</a:t>
+            </a:r>
+            <a:endParaRPr lang="en-US" sz="1100" dirty="0"/>
+          </a:p>
+        </p:txBody>
+      </p:sp>
+      <p:sp>
+        <p:nvSpPr>
+          <p:cNvPr id="127" name="Text 25"/>
+          <p:cNvSpPr txBox="1"/>
+          <p:nvPr/>
+        </p:nvSpPr>
+        <p:spPr>
+          <a:xfrm>
+            <a:off x="2971800" y="5577840"/>
+            <a:ext cx="8458200" cy="502920"/>
+          </a:xfrm>
+          <a:prstGeom prst="rect">
+            <a:avLst/>
+          </a:prstGeom>
+          <a:noFill/>
+          <a:ln/>
+        </p:spPr>
+        <p:txBody>
+          <a:bodyPr wrap="square" lIns="0" tIns="0" rIns="0" bIns="0" rtlCol="0" anchor="ctr"/>
+          <a:lstStyle/>
+          <a:p>
+            <a:pPr indent="0" marL="0">
+              <a:buNone/>
+            </a:pPr>
+            <a:r>
+              <a:rPr lang="en-US" sz="1200" dirty="0">
+                <a:solidFill>
+                  <a:srgbClr val="1F2933"/>
+                </a:solidFill>
+                <a:latin typeface="Arial" pitchFamily="34" charset="0"/>
+                <a:ea typeface="Arial" pitchFamily="34" charset="-122"/>
+                <a:cs typeface="Arial" pitchFamily="34" charset="-120"/>
+              </a:rPr>
+              <a:t>The command line behind everything: “check” runs a round and sends the alerts and summary, “bot” answers Telegram, and “add” / “list” manage the watchlist. GitHub Actions simply runs these commands on a schedule.</a:t>
             </a:r>
             <a:endParaRPr lang="en-US" sz="1200" dirty="0"/>
           </a:p>

</xml_diff>